<commit_message>
Rebalance demo docs and PPT for equal five-target positioning.
</commit_message>
<xml_diff>
--- a/reports/OncoBridge_Demo_Presentation.pptx
+++ b/reports/OncoBridge_Demo_Presentation.pptx
@@ -3117,8 +3117,8 @@
         </p:nvSpPr>
         <p:spPr>
           <a:xfrm>
-            <a:off x="548640" y="1828800"/>
-            <a:ext cx="8046720" cy="1097280"/>
+            <a:off x="548640" y="1691640"/>
+            <a:ext cx="8046720" cy="914400"/>
           </a:xfrm>
           <a:prstGeom prst="rect">
             <a:avLst/>
@@ -3152,22 +3152,22 @@
         </p:nvSpPr>
         <p:spPr>
           <a:xfrm>
-            <a:off x="548640" y="3017520"/>
-            <a:ext cx="8046720" cy="914400"/>
-          </a:xfrm>
-          <a:prstGeom prst="rect">
-            <a:avLst/>
-          </a:prstGeom>
-          <a:noFill/>
-        </p:spPr>
-        <p:txBody>
-          <a:bodyPr wrap="square">
-            <a:spAutoFit/>
-          </a:bodyPr>
-          <a:lstStyle/>
-          <a:p>
-            <a:pPr algn="l">
-              <a:defRPr sz="2000" b="0">
+            <a:off x="548640" y="2788920"/>
+            <a:ext cx="8046720" cy="411480"/>
+          </a:xfrm>
+          <a:prstGeom prst="rect">
+            <a:avLst/>
+          </a:prstGeom>
+          <a:noFill/>
+        </p:spPr>
+        <p:txBody>
+          <a:bodyPr wrap="square">
+            <a:spAutoFit/>
+          </a:bodyPr>
+          <a:lstStyle/>
+          <a:p>
+            <a:pPr algn="l">
+              <a:defRPr sz="1900" b="0">
                 <a:solidFill>
                   <a:srgbClr val="94A3B8"/>
                 </a:solidFill>
@@ -3176,10 +3176,6 @@
             <a:r>
               <a:t>Multi-target theranostics research workbench</a:t>
             </a:r>
-            <a:br/>
-            <a:r>
-              <a:t>CD46 reference case study · 5 targets · 16 modules · Knowledge graph</a:t>
-            </a:r>
           </a:p>
         </p:txBody>
       </p:sp>
@@ -3191,8 +3187,78 @@
         </p:nvSpPr>
         <p:spPr>
           <a:xfrm>
-            <a:off x="548640" y="6217920"/>
-            <a:ext cx="7315200" cy="365760"/>
+            <a:off x="548640" y="3172968"/>
+            <a:ext cx="8046720" cy="411480"/>
+          </a:xfrm>
+          <a:prstGeom prst="rect">
+            <a:avLst/>
+          </a:prstGeom>
+          <a:noFill/>
+        </p:spPr>
+        <p:txBody>
+          <a:bodyPr wrap="square">
+            <a:spAutoFit/>
+          </a:bodyPr>
+          <a:lstStyle/>
+          <a:p>
+            <a:pPr algn="l">
+              <a:defRPr sz="1900" b="0">
+                <a:solidFill>
+                  <a:srgbClr val="94A3B8"/>
+                </a:solidFill>
+              </a:defRPr>
+            </a:pPr>
+            <a:r>
+              <a:t>FOLH1 (PSMA)  ·  FAP  ·  SSTR2  ·  GRPR  ·  CD46</a:t>
+            </a:r>
+          </a:p>
+        </p:txBody>
+      </p:sp>
+      <p:sp>
+        <p:nvSpPr>
+          <p:cNvPr id="5" name="TextBox 4"/>
+          <p:cNvSpPr txBox="1"/>
+          <p:nvPr/>
+        </p:nvSpPr>
+        <p:spPr>
+          <a:xfrm>
+            <a:off x="548640" y="3557015"/>
+            <a:ext cx="8046720" cy="411480"/>
+          </a:xfrm>
+          <a:prstGeom prst="rect">
+            <a:avLst/>
+          </a:prstGeom>
+          <a:noFill/>
+        </p:spPr>
+        <p:txBody>
+          <a:bodyPr wrap="square">
+            <a:spAutoFit/>
+          </a:bodyPr>
+          <a:lstStyle/>
+          <a:p>
+            <a:pPr algn="l">
+              <a:defRPr sz="1900" b="0">
+                <a:solidFill>
+                  <a:srgbClr val="94A3B8"/>
+                </a:solidFill>
+              </a:defRPr>
+            </a:pPr>
+            <a:r>
+              <a:t>16 modules  ·  Knowledge graph  ·  Retrieval-augmented AI</a:t>
+            </a:r>
+          </a:p>
+        </p:txBody>
+      </p:sp>
+      <p:sp>
+        <p:nvSpPr>
+          <p:cNvPr id="6" name="TextBox 5"/>
+          <p:cNvSpPr txBox="1"/>
+          <p:nvPr/>
+        </p:nvSpPr>
+        <p:spPr>
+          <a:xfrm>
+            <a:off x="548640" y="6263640"/>
+            <a:ext cx="7315200" cy="320040"/>
           </a:xfrm>
           <a:prstGeom prst="rect">
             <a:avLst/>
@@ -3274,7 +3340,7 @@
               </a:defRPr>
             </a:pPr>
             <a:r>
-              <a:t>KG Query Explorer — demo query #2</a:t>
+              <a:t>KG Query Explorer — trials &amp; expression</a:t>
             </a:r>
           </a:p>
         </p:txBody>
@@ -3345,14 +3411,14 @@
           <a:lstStyle/>
           <a:p>
             <a:pPr algn="l">
-              <a:defRPr sz="1700" b="0">
-                <a:solidFill>
-                  <a:srgbClr val="1E293B"/>
-                </a:solidFill>
-              </a:defRPr>
-            </a:pPr>
-            <a:r>
-              <a:t>• Template: 🧪 Clinical Trials: Trials investigating CD46?</a:t>
+              <a:defRPr sz="1600" b="0">
+                <a:solidFill>
+                  <a:srgbClr val="1E293B"/>
+                </a:solidFill>
+              </a:defRPr>
+            </a:pPr>
+            <a:r>
+              <a:t>• FOLH1: 🧪 Clinical Trials template → NCT IDs, phase, status</a:t>
             </a:r>
           </a:p>
         </p:txBody>
@@ -3387,7 +3453,7 @@
               </a:defRPr>
             </a:pPr>
             <a:r>
-              <a:t>• Show NCT ID, phase, status columns</a:t>
+              <a:t>• FAP: 📊 Cell lines depending on FAP → DepMap CRISPR scores</a:t>
             </a:r>
           </a:p>
         </p:txBody>
@@ -3422,7 +3488,7 @@
               </a:defRPr>
             </a:pPr>
             <a:r>
-              <a:t>• </a:t>
+              <a:t>• SSTR2: 🎯 Expression — highest cancers for SSTR2</a:t>
             </a:r>
           </a:p>
         </p:txBody>
@@ -3457,7 +3523,7 @@
               </a:defRPr>
             </a:pPr>
             <a:r>
-              <a:t>• Optional — switch target to FOLH1 (PSMA):</a:t>
+              <a:t>• GRPR: 📚 Publications linked to GRPR</a:t>
             </a:r>
           </a:p>
         </p:txBody>
@@ -3492,7 +3558,7 @@
               </a:defRPr>
             </a:pPr>
             <a:r>
-              <a:t>• Same 💊 Drugs template → Pluvicto-era competitive context</a:t>
+              <a:t>• CD46: 📈 Survival — High = worse prognosis</a:t>
             </a:r>
           </a:p>
         </p:txBody>
@@ -3553,7 +3619,7 @@
               </a:defRPr>
             </a:pPr>
             <a:r>
-              <a:t>Research Assistant — demo questions</a:t>
+              <a:t>Research Assistant — per active target</a:t>
             </a:r>
           </a:p>
         </p:txBody>
@@ -3631,7 +3697,7 @@
               </a:defRPr>
             </a:pPr>
             <a:r>
-              <a:t>• Click preset (do not type):</a:t>
+              <a:t>• Select target in bar first — presets update to that gene</a:t>
             </a:r>
           </a:p>
         </p:txBody>
@@ -3644,7 +3710,7 @@
         </p:nvSpPr>
         <p:spPr>
           <a:xfrm>
-            <a:off x="502920" y="1618488"/>
+            <a:off x="502920" y="1847088"/>
             <a:ext cx="8138160" cy="502920"/>
           </a:xfrm>
           <a:prstGeom prst="rect">
@@ -3666,7 +3732,7 @@
               </a:defRPr>
             </a:pPr>
             <a:r>
-              <a:t>• “Summarise CD46 expression across TCGA cancer types with hazard ratios.”</a:t>
+              <a:t>• FOLH1: “Summarise FOLH1 expression across TCGA cancer types with hazard ratios.”</a:t>
             </a:r>
           </a:p>
         </p:txBody>
@@ -3679,7 +3745,7 @@
         </p:nvSpPr>
         <p:spPr>
           <a:xfrm>
-            <a:off x="502920" y="2276856"/>
+            <a:off x="502920" y="2468880"/>
             <a:ext cx="8138160" cy="502920"/>
           </a:xfrm>
           <a:prstGeom prst="rect">
@@ -3701,7 +3767,7 @@
               </a:defRPr>
             </a:pPr>
             <a:r>
-              <a:t>• </a:t>
+              <a:t>• FAP: “What DepMap evidence supports FAP as a cancer dependency?”</a:t>
             </a:r>
           </a:p>
         </p:txBody>
@@ -3714,7 +3780,7 @@
         </p:nvSpPr>
         <p:spPr>
           <a:xfrm>
-            <a:off x="502920" y="2752344"/>
+            <a:off x="502920" y="2944368"/>
             <a:ext cx="8138160" cy="502920"/>
           </a:xfrm>
           <a:prstGeom prst="rect">
@@ -3736,7 +3802,7 @@
               </a:defRPr>
             </a:pPr>
             <a:r>
-              <a:t>• Second preset:</a:t>
+              <a:t>• SSTR2: “What is the current SSTR2-targeted drug pipeline and clinical trials?”</a:t>
             </a:r>
           </a:p>
         </p:txBody>
@@ -3749,7 +3815,7 @@
         </p:nvSpPr>
         <p:spPr>
           <a:xfrm>
-            <a:off x="502920" y="3227832"/>
+            <a:off x="502920" y="3794760"/>
             <a:ext cx="8138160" cy="502920"/>
           </a:xfrm>
           <a:prstGeom prst="rect">
@@ -3771,7 +3837,7 @@
               </a:defRPr>
             </a:pPr>
             <a:r>
-              <a:t>• “What is the current CD46-targeted drug pipeline and which agents are in clinical trials?”</a:t>
+              <a:t>• Say: “Retrieval-augmented — CSVs and graph for the active target.”</a:t>
             </a:r>
           </a:p>
         </p:txBody>
@@ -3779,76 +3845,6 @@
       <p:sp>
         <p:nvSpPr>
           <p:cNvPr id="9" name="TextBox 8"/>
-          <p:cNvSpPr txBox="1"/>
-          <p:nvPr/>
-        </p:nvSpPr>
-        <p:spPr>
-          <a:xfrm>
-            <a:off x="502920" y="3886200"/>
-            <a:ext cx="8138160" cy="502920"/>
-          </a:xfrm>
-          <a:prstGeom prst="rect">
-            <a:avLst/>
-          </a:prstGeom>
-          <a:noFill/>
-        </p:spPr>
-        <p:txBody>
-          <a:bodyPr wrap="square">
-            <a:spAutoFit/>
-          </a:bodyPr>
-          <a:lstStyle/>
-          <a:p>
-            <a:pPr algn="l">
-              <a:defRPr sz="1600" b="0">
-                <a:solidFill>
-                  <a:srgbClr val="1E293B"/>
-                </a:solidFill>
-              </a:defRPr>
-            </a:pPr>
-            <a:r>
-              <a:t>• </a:t>
-            </a:r>
-          </a:p>
-        </p:txBody>
-      </p:sp>
-      <p:sp>
-        <p:nvSpPr>
-          <p:cNvPr id="10" name="TextBox 9"/>
-          <p:cNvSpPr txBox="1"/>
-          <p:nvPr/>
-        </p:nvSpPr>
-        <p:spPr>
-          <a:xfrm>
-            <a:off x="502920" y="4361688"/>
-            <a:ext cx="8138160" cy="502920"/>
-          </a:xfrm>
-          <a:prstGeom prst="rect">
-            <a:avLst/>
-          </a:prstGeom>
-          <a:noFill/>
-        </p:spPr>
-        <p:txBody>
-          <a:bodyPr wrap="square">
-            <a:spAutoFit/>
-          </a:bodyPr>
-          <a:lstStyle/>
-          <a:p>
-            <a:pPr algn="l">
-              <a:defRPr sz="1600" b="0">
-                <a:solidFill>
-                  <a:srgbClr val="1E293B"/>
-                </a:solidFill>
-              </a:defRPr>
-            </a:pPr>
-            <a:r>
-              <a:t>• For CAB audience — use CAB Focus preset buttons</a:t>
-            </a:r>
-          </a:p>
-        </p:txBody>
-      </p:sp>
-      <p:sp>
-        <p:nvSpPr>
-          <p:cNvPr id="11" name="TextBox 10"/>
           <p:cNvSpPr txBox="1"/>
           <p:nvPr/>
         </p:nvSpPr>
@@ -4050,7 +4046,7 @@
               </a:defRPr>
             </a:pPr>
             <a:r>
-              <a:t>• mCRPC — metastatic castration-resistant prostate cancer</a:t>
+              <a:t>• RLT — radioligand therapy</a:t>
             </a:r>
           </a:p>
         </p:txBody>
@@ -4085,7 +4081,7 @@
               </a:defRPr>
             </a:pPr>
             <a:r>
-              <a:t>• RLT — radioligand therapy (radioactive drug binds target)</a:t>
+              <a:t>• PSMA / FOLH1 — prostate surface target</a:t>
             </a:r>
           </a:p>
         </p:txBody>
@@ -4120,7 +4116,7 @@
               </a:defRPr>
             </a:pPr>
             <a:r>
-              <a:t>• PSMA / FOLH1 — prostate surface target</a:t>
+              <a:t>• FAP — fibroblast activation protein (stroma)</a:t>
             </a:r>
           </a:p>
         </p:txBody>
@@ -4155,7 +4151,7 @@
               </a:defRPr>
             </a:pPr>
             <a:r>
-              <a:t>• GENIE — AACR real-world sequencing registry</a:t>
+              <a:t>• SSTR2 — somatostatin receptor (neuroendocrine)</a:t>
             </a:r>
           </a:p>
         </p:txBody>
@@ -4190,7 +4186,7 @@
               </a:defRPr>
             </a:pPr>
             <a:r>
-              <a:t>• HR — hazard ratio (&gt;1 = worse survival)</a:t>
+              <a:t>• GRPR — gastrin-releasing peptide receptor</a:t>
             </a:r>
           </a:p>
         </p:txBody>
@@ -4225,7 +4221,7 @@
               </a:defRPr>
             </a:pPr>
             <a:r>
-              <a:t>• NCT — clinical trial registry number</a:t>
+              <a:t>• GENIE — AACR real-world sequencing registry</a:t>
             </a:r>
           </a:p>
         </p:txBody>
@@ -4260,7 +4256,7 @@
               </a:defRPr>
             </a:pPr>
             <a:r>
-              <a:t>• KG — knowledge graph (Neo4j)</a:t>
+              <a:t>• NCT — clinical trial registry number</a:t>
             </a:r>
           </a:p>
         </p:txBody>
@@ -4321,7 +4317,7 @@
               </a:defRPr>
             </a:pPr>
             <a:r>
-              <a:t>Honest positioning</a:t>
+              <a:t>Platform positioning</a:t>
             </a:r>
           </a:p>
         </p:txBody>
@@ -4392,14 +4388,14 @@
           <a:lstStyle/>
           <a:p>
             <a:pPr algn="l">
-              <a:defRPr sz="1700" b="0">
-                <a:solidFill>
-                  <a:srgbClr val="1E293B"/>
-                </a:solidFill>
-              </a:defRPr>
-            </a:pPr>
-            <a:r>
-              <a:t>• CD46 = full reference case study (eligibility, biomarkers, diagnostics depth)</a:t>
+              <a:defRPr sz="1600" b="0">
+                <a:solidFill>
+                  <a:srgbClr val="1E293B"/>
+                </a:solidFill>
+              </a:defRPr>
+            </a:pPr>
+            <a:r>
+              <a:t>• One workbench — five theranostic surface targets</a:t>
             </a:r>
           </a:p>
         </p:txBody>
@@ -4412,7 +4408,7 @@
         </p:nvSpPr>
         <p:spPr>
           <a:xfrm>
-            <a:off x="502920" y="1801368"/>
+            <a:off x="502920" y="1618488"/>
             <a:ext cx="8138160" cy="502920"/>
           </a:xfrm>
           <a:prstGeom prst="rect">
@@ -4434,7 +4430,7 @@
               </a:defRPr>
             </a:pPr>
             <a:r>
-              <a:t>• FOLH1, FAP, SSTR2, GRPR = medium open-data slices</a:t>
+              <a:t>• Same modules, datasets, and knowledge graph for each registered gene</a:t>
             </a:r>
           </a:p>
         </p:txBody>
@@ -4447,7 +4443,7 @@
         </p:nvSpPr>
         <p:spPr>
           <a:xfrm>
-            <a:off x="502920" y="2276856"/>
+            <a:off x="502920" y="2093976"/>
             <a:ext cx="8138160" cy="502920"/>
           </a:xfrm>
           <a:prstGeom prst="rect">
@@ -4469,7 +4465,7 @@
               </a:defRPr>
             </a:pPr>
             <a:r>
-              <a:t>• Expression, survival, trials, PPI, and KG templates work for all five</a:t>
+              <a:t>• Target bar is the primary switch — audience should see you rotate it</a:t>
             </a:r>
           </a:p>
         </p:txBody>
@@ -4482,7 +4478,7 @@
         </p:nvSpPr>
         <p:spPr>
           <a:xfrm>
-            <a:off x="502920" y="2935224"/>
+            <a:off x="502920" y="2569464"/>
             <a:ext cx="8138160" cy="502920"/>
           </a:xfrm>
           <a:prstGeom prst="rect">
@@ -4543,8 +4539,8 @@
         </p:nvSpPr>
         <p:spPr>
           <a:xfrm>
-            <a:off x="548640" y="1828800"/>
-            <a:ext cx="8046720" cy="1097280"/>
+            <a:off x="548640" y="1691640"/>
+            <a:ext cx="8046720" cy="914400"/>
           </a:xfrm>
           <a:prstGeom prst="rect">
             <a:avLst/>
@@ -4578,22 +4574,22 @@
         </p:nvSpPr>
         <p:spPr>
           <a:xfrm>
-            <a:off x="548640" y="3017520"/>
-            <a:ext cx="8046720" cy="914400"/>
-          </a:xfrm>
-          <a:prstGeom prst="rect">
-            <a:avLst/>
-          </a:prstGeom>
-          <a:noFill/>
-        </p:spPr>
-        <p:txBody>
-          <a:bodyPr wrap="square">
-            <a:spAutoFit/>
-          </a:bodyPr>
-          <a:lstStyle/>
-          <a:p>
-            <a:pPr algn="l">
-              <a:defRPr sz="2000" b="0">
+            <a:off x="548640" y="2788920"/>
+            <a:ext cx="8046720" cy="411480"/>
+          </a:xfrm>
+          <a:prstGeom prst="rect">
+            <a:avLst/>
+          </a:prstGeom>
+          <a:noFill/>
+        </p:spPr>
+        <p:txBody>
+          <a:bodyPr wrap="square">
+            <a:spAutoFit/>
+          </a:bodyPr>
+          <a:lstStyle/>
+          <a:p>
+            <a:pPr algn="l">
+              <a:defRPr sz="1900" b="0">
                 <a:solidFill>
                   <a:srgbClr val="94A3B8"/>
                 </a:solidFill>
@@ -4602,12 +4598,73 @@
             <a:r>
               <a:t>OncoBridge Intelligence</a:t>
             </a:r>
-            <a:br/>
+          </a:p>
+        </p:txBody>
+      </p:sp>
+      <p:sp>
+        <p:nvSpPr>
+          <p:cNvPr id="4" name="TextBox 3"/>
+          <p:cNvSpPr txBox="1"/>
+          <p:nvPr/>
+        </p:nvSpPr>
+        <p:spPr>
+          <a:xfrm>
+            <a:off x="548640" y="3172968"/>
+            <a:ext cx="8046720" cy="411480"/>
+          </a:xfrm>
+          <a:prstGeom prst="rect">
+            <a:avLst/>
+          </a:prstGeom>
+          <a:noFill/>
+        </p:spPr>
+        <p:txBody>
+          <a:bodyPr wrap="square">
+            <a:spAutoFit/>
+          </a:bodyPr>
+          <a:lstStyle/>
+          <a:p>
+            <a:pPr algn="l">
+              <a:defRPr sz="1900" b="0">
+                <a:solidFill>
+                  <a:srgbClr val="94A3B8"/>
+                </a:solidFill>
+              </a:defRPr>
+            </a:pPr>
             <a:r>
               <a:t>oncobridge.eurthtech.com</a:t>
             </a:r>
-            <a:br/>
-            <a:br/>
+          </a:p>
+        </p:txBody>
+      </p:sp>
+      <p:sp>
+        <p:nvSpPr>
+          <p:cNvPr id="5" name="TextBox 4"/>
+          <p:cNvSpPr txBox="1"/>
+          <p:nvPr/>
+        </p:nvSpPr>
+        <p:spPr>
+          <a:xfrm>
+            <a:off x="548640" y="3557015"/>
+            <a:ext cx="8046720" cy="411480"/>
+          </a:xfrm>
+          <a:prstGeom prst="rect">
+            <a:avLst/>
+          </a:prstGeom>
+          <a:noFill/>
+        </p:spPr>
+        <p:txBody>
+          <a:bodyPr wrap="square">
+            <a:spAutoFit/>
+          </a:bodyPr>
+          <a:lstStyle/>
+          <a:p>
+            <a:pPr algn="l">
+              <a:defRPr sz="1900" b="0">
+                <a:solidFill>
+                  <a:srgbClr val="94A3B8"/>
+                </a:solidFill>
+              </a:defRPr>
+            </a:pPr>
             <a:r>
               <a:t>Questions?</a:t>
             </a:r>
@@ -4616,14 +4673,14 @@
       </p:sp>
       <p:sp>
         <p:nvSpPr>
-          <p:cNvPr id="4" name="TextBox 3"/>
-          <p:cNvSpPr txBox="1"/>
-          <p:nvPr/>
-        </p:nvSpPr>
-        <p:spPr>
-          <a:xfrm>
-            <a:off x="548640" y="6217920"/>
-            <a:ext cx="7315200" cy="365760"/>
+          <p:cNvPr id="6" name="TextBox 5"/>
+          <p:cNvSpPr txBox="1"/>
+          <p:nvPr/>
+        </p:nvSpPr>
+        <p:spPr>
+          <a:xfrm>
+            <a:off x="548640" y="6263640"/>
+            <a:ext cx="7315200" cy="320040"/>
           </a:xfrm>
           <a:prstGeom prst="rect">
             <a:avLst/>
@@ -4776,14 +4833,14 @@
           <a:lstStyle/>
           <a:p>
             <a:pPr algn="l">
-              <a:defRPr sz="1700" b="0">
-                <a:solidFill>
-                  <a:srgbClr val="1E293B"/>
-                </a:solidFill>
-              </a:defRPr>
-            </a:pPr>
-            <a:r>
-              <a:t>• Radioligand / surface-antigen programs need dozens of disconnected datasets</a:t>
+              <a:defRPr sz="1600" b="0">
+                <a:solidFill>
+                  <a:srgbClr val="1E293B"/>
+                </a:solidFill>
+              </a:defRPr>
+            </a:pPr>
+            <a:r>
+              <a:t>• Radioligand programs need expression, safety, patients, trials, and literature — in one place</a:t>
             </a:r>
           </a:p>
         </p:txBody>
@@ -4796,7 +4853,7 @@
         </p:nvSpPr>
         <p:spPr>
           <a:xfrm>
-            <a:off x="502920" y="1801368"/>
+            <a:off x="502920" y="1764792"/>
             <a:ext cx="8138160" cy="502920"/>
           </a:xfrm>
           <a:prstGeom prst="rect">
@@ -4818,7 +4875,7 @@
               </a:defRPr>
             </a:pPr>
             <a:r>
-              <a:t>• TCGA, GENIE, trials, ChEMBL, protein atlases — each with different formats</a:t>
+              <a:t>• Public data lives in TCGA, GENIE, HPA, ChEMBL, ClinicalTrials.gov — disconnected formats</a:t>
             </a:r>
           </a:p>
         </p:txBody>
@@ -4831,7 +4888,7 @@
         </p:nvSpPr>
         <p:spPr>
           <a:xfrm>
-            <a:off x="502920" y="2459736"/>
+            <a:off x="502920" y="2386584"/>
             <a:ext cx="8138160" cy="502920"/>
           </a:xfrm>
           <a:prstGeom prst="rect">
@@ -4853,7 +4910,7 @@
               </a:defRPr>
             </a:pPr>
             <a:r>
-              <a:t>• Generic AI (ChatGPT) generates plausible oncology text without verifiable numbers</a:t>
+              <a:t>• Generic AI generates plausible oncology text without verifiable numbers</a:t>
             </a:r>
           </a:p>
         </p:txBody>
@@ -4866,7 +4923,7 @@
         </p:nvSpPr>
         <p:spPr>
           <a:xfrm>
-            <a:off x="502920" y="3118104"/>
+            <a:off x="502920" y="3008376"/>
             <a:ext cx="8138160" cy="502920"/>
           </a:xfrm>
           <a:prstGeom prst="rect">
@@ -4888,7 +4945,7 @@
               </a:defRPr>
             </a:pPr>
             <a:r>
-              <a:t>• Teams lack a single workbench to go from target → patient → trial → strategy</a:t>
+              <a:t>• Teams need one workbench across multiple surface targets — not one gene at a time</a:t>
             </a:r>
           </a:p>
         </p:txBody>
@@ -5020,7 +5077,7 @@
           <a:lstStyle/>
           <a:p>
             <a:pPr algn="l">
-              <a:defRPr sz="1700" b="0">
+              <a:defRPr sz="1600" b="0">
                 <a:solidFill>
                   <a:srgbClr val="1E293B"/>
                 </a:solidFill>
@@ -5062,7 +5119,7 @@
               </a:defRPr>
             </a:pPr>
             <a:r>
-              <a:t>• 16 modules across 9 research dimensions</a:t>
+              <a:t>• Five theranostic targets on one shared architecture</a:t>
             </a:r>
           </a:p>
         </p:txBody>
@@ -5097,7 +5154,7 @@
               </a:defRPr>
             </a:pPr>
             <a:r>
-              <a:t>• 5 theranostic targets: CD46, PSMA (FOLH1), FAP, SSTR2, GRPR</a:t>
+              <a:t>• 16 modules across 9 research dimensions</a:t>
             </a:r>
           </a:p>
         </p:txBody>
@@ -5132,7 +5189,7 @@
               </a:defRPr>
             </a:pPr>
             <a:r>
-              <a:t>• Neo4j knowledge graph (~3,586 nodes) linking genes, drugs, trials, publications</a:t>
+              <a:t>• Neo4j knowledge graph (~3,586 nodes) — genes, drugs, trials, publications linked</a:t>
             </a:r>
           </a:p>
         </p:txBody>
@@ -5145,7 +5202,7 @@
         </p:nvSpPr>
         <p:spPr>
           <a:xfrm>
-            <a:off x="502920" y="3227832"/>
+            <a:off x="502920" y="3191256"/>
             <a:ext cx="8138160" cy="502920"/>
           </a:xfrm>
           <a:prstGeom prst="rect">
@@ -5167,7 +5224,7 @@
               </a:defRPr>
             </a:pPr>
             <a:r>
-              <a:t>• Retrieval-augmented AI — retrieves your data, then explains it</a:t>
+              <a:t>• Target bar switches the active gene — charts, KG queries, and AI follow your selection</a:t>
             </a:r>
           </a:p>
         </p:txBody>
@@ -5263,7 +5320,7 @@
               </a:defRPr>
             </a:pPr>
             <a:r>
-              <a:t>Five targets — plain English</a:t>
+              <a:t>Five theranostic targets — equal platform scope</a:t>
             </a:r>
           </a:p>
         </p:txBody>
@@ -5276,29 +5333,29 @@
         </p:nvSpPr>
         <p:spPr>
           <a:xfrm>
-            <a:off x="457200" y="1097280"/>
-            <a:ext cx="3840480" cy="365760"/>
-          </a:xfrm>
-          <a:prstGeom prst="rect">
-            <a:avLst/>
-          </a:prstGeom>
-          <a:noFill/>
-        </p:spPr>
-        <p:txBody>
-          <a:bodyPr wrap="square">
-            <a:spAutoFit/>
-          </a:bodyPr>
-          <a:lstStyle/>
-          <a:p>
-            <a:pPr algn="l">
-              <a:defRPr sz="1600" b="1">
+            <a:off x="502920" y="1234440"/>
+            <a:ext cx="1828800" cy="320040"/>
+          </a:xfrm>
+          <a:prstGeom prst="rect">
+            <a:avLst/>
+          </a:prstGeom>
+          <a:noFill/>
+        </p:spPr>
+        <p:txBody>
+          <a:bodyPr wrap="square">
+            <a:spAutoFit/>
+          </a:bodyPr>
+          <a:lstStyle/>
+          <a:p>
+            <a:pPr algn="l">
+              <a:defRPr sz="1700" b="1">
                 <a:solidFill>
                   <a:srgbClr val="2563EB"/>
                 </a:solidFill>
               </a:defRPr>
             </a:pPr>
             <a:r>
-              <a:t>CD46 · FOLH1 (PSMA)</a:t>
+              <a:t>FOLH1 (PSMA)</a:t>
             </a:r>
           </a:p>
         </p:txBody>
@@ -5311,29 +5368,29 @@
         </p:nvSpPr>
         <p:spPr>
           <a:xfrm>
-            <a:off x="457200" y="1508760"/>
-            <a:ext cx="3931920" cy="457200"/>
-          </a:xfrm>
-          <a:prstGeom prst="rect">
-            <a:avLst/>
-          </a:prstGeom>
-          <a:noFill/>
-        </p:spPr>
-        <p:txBody>
-          <a:bodyPr wrap="square">
-            <a:spAutoFit/>
-          </a:bodyPr>
-          <a:lstStyle/>
-          <a:p>
-            <a:pPr algn="l">
-              <a:defRPr sz="1400" b="0">
-                <a:solidFill>
-                  <a:srgbClr val="1E293B"/>
-                </a:solidFill>
-              </a:defRPr>
-            </a:pPr>
-            <a:r>
-              <a:t>• Complement evasion surface antigen</a:t>
+            <a:off x="2377440" y="1234440"/>
+            <a:ext cx="6217920" cy="411480"/>
+          </a:xfrm>
+          <a:prstGeom prst="rect">
+            <a:avLst/>
+          </a:prstGeom>
+          <a:noFill/>
+        </p:spPr>
+        <p:txBody>
+          <a:bodyPr wrap="square">
+            <a:spAutoFit/>
+          </a:bodyPr>
+          <a:lstStyle/>
+          <a:p>
+            <a:pPr algn="l">
+              <a:defRPr sz="1500" b="0">
+                <a:solidFill>
+                  <a:srgbClr val="1E293B"/>
+                </a:solidFill>
+              </a:defRPr>
+            </a:pPr>
+            <a:r>
+              <a:t>Prostate radioligand benchmark · Pluvicto® class</a:t>
             </a:r>
           </a:p>
         </p:txBody>
@@ -5346,29 +5403,29 @@
         </p:nvSpPr>
         <p:spPr>
           <a:xfrm>
-            <a:off x="457200" y="1947672"/>
-            <a:ext cx="3931920" cy="457200"/>
-          </a:xfrm>
-          <a:prstGeom prst="rect">
-            <a:avLst/>
-          </a:prstGeom>
-          <a:noFill/>
-        </p:spPr>
-        <p:txBody>
-          <a:bodyPr wrap="square">
-            <a:spAutoFit/>
-          </a:bodyPr>
-          <a:lstStyle/>
-          <a:p>
-            <a:pPr algn="l">
-              <a:defRPr sz="1400" b="0">
-                <a:solidFill>
-                  <a:srgbClr val="1E293B"/>
-                </a:solidFill>
-              </a:defRPr>
-            </a:pPr>
-            <a:r>
-              <a:t>• Pan-cancer; mCRPC case study</a:t>
+            <a:off x="502920" y="2103120"/>
+            <a:ext cx="1828800" cy="320040"/>
+          </a:xfrm>
+          <a:prstGeom prst="rect">
+            <a:avLst/>
+          </a:prstGeom>
+          <a:noFill/>
+        </p:spPr>
+        <p:txBody>
+          <a:bodyPr wrap="square">
+            <a:spAutoFit/>
+          </a:bodyPr>
+          <a:lstStyle/>
+          <a:p>
+            <a:pPr algn="l">
+              <a:defRPr sz="1700" b="1">
+                <a:solidFill>
+                  <a:srgbClr val="2563EB"/>
+                </a:solidFill>
+              </a:defRPr>
+            </a:pPr>
+            <a:r>
+              <a:t>FAP</a:t>
             </a:r>
           </a:p>
         </p:txBody>
@@ -5381,29 +5438,29 @@
         </p:nvSpPr>
         <p:spPr>
           <a:xfrm>
-            <a:off x="457200" y="2386584"/>
-            <a:ext cx="3931920" cy="457200"/>
-          </a:xfrm>
-          <a:prstGeom prst="rect">
-            <a:avLst/>
-          </a:prstGeom>
-          <a:noFill/>
-        </p:spPr>
-        <p:txBody>
-          <a:bodyPr wrap="square">
-            <a:spAutoFit/>
-          </a:bodyPr>
-          <a:lstStyle/>
-          <a:p>
-            <a:pPr algn="l">
-              <a:defRPr sz="1400" b="0">
-                <a:solidFill>
-                  <a:srgbClr val="1E293B"/>
-                </a:solidFill>
-              </a:defRPr>
-            </a:pPr>
-            <a:r>
-              <a:t>• Alpha radioligand (α-RLT) focus</a:t>
+            <a:off x="2377440" y="2103120"/>
+            <a:ext cx="6217920" cy="411480"/>
+          </a:xfrm>
+          <a:prstGeom prst="rect">
+            <a:avLst/>
+          </a:prstGeom>
+          <a:noFill/>
+        </p:spPr>
+        <p:txBody>
+          <a:bodyPr wrap="square">
+            <a:spAutoFit/>
+          </a:bodyPr>
+          <a:lstStyle/>
+          <a:p>
+            <a:pPr algn="l">
+              <a:defRPr sz="1500" b="0">
+                <a:solidFill>
+                  <a:srgbClr val="1E293B"/>
+                </a:solidFill>
+              </a:defRPr>
+            </a:pPr>
+            <a:r>
+              <a:t>Stromal / CAF target · FAPI PET &amp; emerging RLT</a:t>
             </a:r>
           </a:p>
         </p:txBody>
@@ -5416,29 +5473,29 @@
         </p:nvSpPr>
         <p:spPr>
           <a:xfrm>
-            <a:off x="457200" y="2825496"/>
-            <a:ext cx="3931920" cy="457200"/>
-          </a:xfrm>
-          <a:prstGeom prst="rect">
-            <a:avLst/>
-          </a:prstGeom>
-          <a:noFill/>
-        </p:spPr>
-        <p:txBody>
-          <a:bodyPr wrap="square">
-            <a:spAutoFit/>
-          </a:bodyPr>
-          <a:lstStyle/>
-          <a:p>
-            <a:pPr algn="l">
-              <a:defRPr sz="1400" b="0">
-                <a:solidFill>
-                  <a:srgbClr val="1E293B"/>
-                </a:solidFill>
-              </a:defRPr>
-            </a:pPr>
-            <a:r>
-              <a:t>• Prostate membrane antigen</a:t>
+            <a:off x="502920" y="2971800"/>
+            <a:ext cx="1828800" cy="320040"/>
+          </a:xfrm>
+          <a:prstGeom prst="rect">
+            <a:avLst/>
+          </a:prstGeom>
+          <a:noFill/>
+        </p:spPr>
+        <p:txBody>
+          <a:bodyPr wrap="square">
+            <a:spAutoFit/>
+          </a:bodyPr>
+          <a:lstStyle/>
+          <a:p>
+            <a:pPr algn="l">
+              <a:defRPr sz="1700" b="1">
+                <a:solidFill>
+                  <a:srgbClr val="2563EB"/>
+                </a:solidFill>
+              </a:defRPr>
+            </a:pPr>
+            <a:r>
+              <a:t>SSTR2</a:t>
             </a:r>
           </a:p>
         </p:txBody>
@@ -5451,29 +5508,29 @@
         </p:nvSpPr>
         <p:spPr>
           <a:xfrm>
-            <a:off x="457200" y="3264408"/>
-            <a:ext cx="3931920" cy="457200"/>
-          </a:xfrm>
-          <a:prstGeom prst="rect">
-            <a:avLst/>
-          </a:prstGeom>
-          <a:noFill/>
-        </p:spPr>
-        <p:txBody>
-          <a:bodyPr wrap="square">
-            <a:spAutoFit/>
-          </a:bodyPr>
-          <a:lstStyle/>
-          <a:p>
-            <a:pPr algn="l">
-              <a:defRPr sz="1400" b="0">
-                <a:solidFill>
-                  <a:srgbClr val="1E293B"/>
-                </a:solidFill>
-              </a:defRPr>
-            </a:pPr>
-            <a:r>
-              <a:t>• Pluvicto® benchmark target</a:t>
+            <a:off x="2377440" y="2971800"/>
+            <a:ext cx="6217920" cy="411480"/>
+          </a:xfrm>
+          <a:prstGeom prst="rect">
+            <a:avLst/>
+          </a:prstGeom>
+          <a:noFill/>
+        </p:spPr>
+        <p:txBody>
+          <a:bodyPr wrap="square">
+            <a:spAutoFit/>
+          </a:bodyPr>
+          <a:lstStyle/>
+          <a:p>
+            <a:pPr algn="l">
+              <a:defRPr sz="1500" b="0">
+                <a:solidFill>
+                  <a:srgbClr val="1E293B"/>
+                </a:solidFill>
+              </a:defRPr>
+            </a:pPr>
+            <a:r>
+              <a:t>Neuroendocrine GPCR · somatostatin analog RLT</a:t>
             </a:r>
           </a:p>
         </p:txBody>
@@ -5486,29 +5543,29 @@
         </p:nvSpPr>
         <p:spPr>
           <a:xfrm>
-            <a:off x="4572000" y="1097280"/>
-            <a:ext cx="3840480" cy="365760"/>
-          </a:xfrm>
-          <a:prstGeom prst="rect">
-            <a:avLst/>
-          </a:prstGeom>
-          <a:noFill/>
-        </p:spPr>
-        <p:txBody>
-          <a:bodyPr wrap="square">
-            <a:spAutoFit/>
-          </a:bodyPr>
-          <a:lstStyle/>
-          <a:p>
-            <a:pPr algn="l">
-              <a:defRPr sz="1600" b="1">
+            <a:off x="502920" y="3840480"/>
+            <a:ext cx="1828800" cy="320040"/>
+          </a:xfrm>
+          <a:prstGeom prst="rect">
+            <a:avLst/>
+          </a:prstGeom>
+          <a:noFill/>
+        </p:spPr>
+        <p:txBody>
+          <a:bodyPr wrap="square">
+            <a:spAutoFit/>
+          </a:bodyPr>
+          <a:lstStyle/>
+          <a:p>
+            <a:pPr algn="l">
+              <a:defRPr sz="1700" b="1">
                 <a:solidFill>
                   <a:srgbClr val="2563EB"/>
                 </a:solidFill>
               </a:defRPr>
             </a:pPr>
             <a:r>
-              <a:t>FAP · SSTR2 · GRPR</a:t>
+              <a:t>GRPR</a:t>
             </a:r>
           </a:p>
         </p:txBody>
@@ -5521,29 +5578,29 @@
         </p:nvSpPr>
         <p:spPr>
           <a:xfrm>
-            <a:off x="4572000" y="1508760"/>
-            <a:ext cx="3931920" cy="457200"/>
-          </a:xfrm>
-          <a:prstGeom prst="rect">
-            <a:avLst/>
-          </a:prstGeom>
-          <a:noFill/>
-        </p:spPr>
-        <p:txBody>
-          <a:bodyPr wrap="square">
-            <a:spAutoFit/>
-          </a:bodyPr>
-          <a:lstStyle/>
-          <a:p>
-            <a:pPr algn="l">
-              <a:defRPr sz="1400" b="0">
-                <a:solidFill>
-                  <a:srgbClr val="1E293B"/>
-                </a:solidFill>
-              </a:defRPr>
-            </a:pPr>
-            <a:r>
-              <a:t>• Cancer-associated fibroblast marker</a:t>
+            <a:off x="2377440" y="3840480"/>
+            <a:ext cx="6217920" cy="411480"/>
+          </a:xfrm>
+          <a:prstGeom prst="rect">
+            <a:avLst/>
+          </a:prstGeom>
+          <a:noFill/>
+        </p:spPr>
+        <p:txBody>
+          <a:bodyPr wrap="square">
+            <a:spAutoFit/>
+          </a:bodyPr>
+          <a:lstStyle/>
+          <a:p>
+            <a:pPr algn="l">
+              <a:defRPr sz="1500" b="0">
+                <a:solidFill>
+                  <a:srgbClr val="1E293B"/>
+                </a:solidFill>
+              </a:defRPr>
+            </a:pPr>
+            <a:r>
+              <a:t>Solid-tumour GPCR · bombesin-analogue radioligands</a:t>
             </a:r>
           </a:p>
         </p:txBody>
@@ -5556,29 +5613,29 @@
         </p:nvSpPr>
         <p:spPr>
           <a:xfrm>
-            <a:off x="4572000" y="1947672"/>
-            <a:ext cx="3931920" cy="457200"/>
-          </a:xfrm>
-          <a:prstGeom prst="rect">
-            <a:avLst/>
-          </a:prstGeom>
-          <a:noFill/>
-        </p:spPr>
-        <p:txBody>
-          <a:bodyPr wrap="square">
-            <a:spAutoFit/>
-          </a:bodyPr>
-          <a:lstStyle/>
-          <a:p>
-            <a:pPr algn="l">
-              <a:defRPr sz="1400" b="0">
-                <a:solidFill>
-                  <a:srgbClr val="1E293B"/>
-                </a:solidFill>
-              </a:defRPr>
-            </a:pPr>
-            <a:r>
-              <a:t>• FAPI PET / emerging RLT</a:t>
+            <a:off x="502920" y="4709160"/>
+            <a:ext cx="1828800" cy="320040"/>
+          </a:xfrm>
+          <a:prstGeom prst="rect">
+            <a:avLst/>
+          </a:prstGeom>
+          <a:noFill/>
+        </p:spPr>
+        <p:txBody>
+          <a:bodyPr wrap="square">
+            <a:spAutoFit/>
+          </a:bodyPr>
+          <a:lstStyle/>
+          <a:p>
+            <a:pPr algn="l">
+              <a:defRPr sz="1700" b="1">
+                <a:solidFill>
+                  <a:srgbClr val="2563EB"/>
+                </a:solidFill>
+              </a:defRPr>
+            </a:pPr>
+            <a:r>
+              <a:t>CD46</a:t>
             </a:r>
           </a:p>
         </p:txBody>
@@ -5591,29 +5648,29 @@
         </p:nvSpPr>
         <p:spPr>
           <a:xfrm>
-            <a:off x="4572000" y="2386584"/>
-            <a:ext cx="3931920" cy="457200"/>
-          </a:xfrm>
-          <a:prstGeom prst="rect">
-            <a:avLst/>
-          </a:prstGeom>
-          <a:noFill/>
-        </p:spPr>
-        <p:txBody>
-          <a:bodyPr wrap="square">
-            <a:spAutoFit/>
-          </a:bodyPr>
-          <a:lstStyle/>
-          <a:p>
-            <a:pPr algn="l">
-              <a:defRPr sz="1400" b="0">
-                <a:solidFill>
-                  <a:srgbClr val="1E293B"/>
-                </a:solidFill>
-              </a:defRPr>
-            </a:pPr>
-            <a:r>
-              <a:t>• Neuroendocrine receptor (Lutathera® class)</a:t>
+            <a:off x="2377440" y="4709160"/>
+            <a:ext cx="6217920" cy="411480"/>
+          </a:xfrm>
+          <a:prstGeom prst="rect">
+            <a:avLst/>
+          </a:prstGeom>
+          <a:noFill/>
+        </p:spPr>
+        <p:txBody>
+          <a:bodyPr wrap="square">
+            <a:spAutoFit/>
+          </a:bodyPr>
+          <a:lstStyle/>
+          <a:p>
+            <a:pPr algn="l">
+              <a:defRPr sz="1500" b="0">
+                <a:solidFill>
+                  <a:srgbClr val="1E293B"/>
+                </a:solidFill>
+              </a:defRPr>
+            </a:pPr>
+            <a:r>
+              <a:t>Pan-cancer surface antigen · complement pathway</a:t>
             </a:r>
           </a:p>
         </p:txBody>
@@ -5626,64 +5683,29 @@
         </p:nvSpPr>
         <p:spPr>
           <a:xfrm>
-            <a:off x="4572000" y="2825496"/>
-            <a:ext cx="3931920" cy="457200"/>
-          </a:xfrm>
-          <a:prstGeom prst="rect">
-            <a:avLst/>
-          </a:prstGeom>
-          <a:noFill/>
-        </p:spPr>
-        <p:txBody>
-          <a:bodyPr wrap="square">
-            <a:spAutoFit/>
-          </a:bodyPr>
-          <a:lstStyle/>
-          <a:p>
-            <a:pPr algn="l">
-              <a:defRPr sz="1400" b="0">
-                <a:solidFill>
-                  <a:srgbClr val="1E293B"/>
-                </a:solidFill>
-              </a:defRPr>
-            </a:pPr>
-            <a:r>
-              <a:t>• Lung / solid tumour GPCR target</a:t>
-            </a:r>
-          </a:p>
-        </p:txBody>
-      </p:sp>
-      <p:sp>
-        <p:nvSpPr>
-          <p:cNvPr id="14" name="TextBox 13"/>
-          <p:cNvSpPr txBox="1"/>
-          <p:nvPr/>
-        </p:nvSpPr>
-        <p:spPr>
-          <a:xfrm>
-            <a:off x="4572000" y="3264408"/>
-            <a:ext cx="3931920" cy="457200"/>
-          </a:xfrm>
-          <a:prstGeom prst="rect">
-            <a:avLst/>
-          </a:prstGeom>
-          <a:noFill/>
-        </p:spPr>
-        <p:txBody>
-          <a:bodyPr wrap="square">
-            <a:spAutoFit/>
-          </a:bodyPr>
-          <a:lstStyle/>
-          <a:p>
-            <a:pPr algn="l">
-              <a:defRPr sz="1400" b="0">
-                <a:solidFill>
-                  <a:srgbClr val="1E293B"/>
-                </a:solidFill>
-              </a:defRPr>
-            </a:pPr>
-            <a:r>
-              <a:t>• Bombesin-analogue radioligands</a:t>
+            <a:off x="502920" y="6172200"/>
+            <a:ext cx="8138160" cy="365760"/>
+          </a:xfrm>
+          <a:prstGeom prst="rect">
+            <a:avLst/>
+          </a:prstGeom>
+          <a:noFill/>
+        </p:spPr>
+        <p:txBody>
+          <a:bodyPr wrap="square">
+            <a:spAutoFit/>
+          </a:bodyPr>
+          <a:lstStyle/>
+          <a:p>
+            <a:pPr algn="l">
+              <a:defRPr sz="1200" b="0">
+                <a:solidFill>
+                  <a:srgbClr val="64748B"/>
+                </a:solidFill>
+              </a:defRPr>
+            </a:pPr>
+            <a:r>
+              <a:t>Switch any module via the target bar — same datasets, same graph schema, same sixteen modules.</a:t>
             </a:r>
           </a:p>
         </p:txBody>
@@ -6163,7 +6185,7 @@
               </a:defRPr>
             </a:pPr>
             <a:r>
-              <a:t>Datasets included (name-drop for credibility)</a:t>
+              <a:t>Datasets included</a:t>
             </a:r>
           </a:p>
         </p:txBody>
@@ -6241,7 +6263,7 @@
               </a:defRPr>
             </a:pPr>
             <a:r>
-              <a:t>• TCGA / UCSC Xena — pan-cancer RNA &amp; survival (US government genomics)</a:t>
+              <a:t>• TCGA / UCSC Xena — pan-cancer RNA &amp; survival</a:t>
             </a:r>
           </a:p>
         </p:txBody>
@@ -6254,7 +6276,7 @@
         </p:nvSpPr>
         <p:spPr>
           <a:xfrm>
-            <a:off x="502920" y="1801368"/>
+            <a:off x="502920" y="1618488"/>
             <a:ext cx="8138160" cy="502920"/>
           </a:xfrm>
           <a:prstGeom prst="rect">
@@ -6289,7 +6311,7 @@
         </p:nvSpPr>
         <p:spPr>
           <a:xfrm>
-            <a:off x="502920" y="2276856"/>
+            <a:off x="502920" y="2093976"/>
             <a:ext cx="8138160" cy="502920"/>
           </a:xfrm>
           <a:prstGeom prst="rect">
@@ -6311,7 +6333,7 @@
               </a:defRPr>
             </a:pPr>
             <a:r>
-              <a:t>• Human Protein Atlas (HPA) — protein tissue staining</a:t>
+              <a:t>• Human Protein Atlas · GTEx · DepMap</a:t>
             </a:r>
           </a:p>
         </p:txBody>
@@ -6324,7 +6346,7 @@
         </p:nvSpPr>
         <p:spPr>
           <a:xfrm>
-            <a:off x="502920" y="2752344"/>
+            <a:off x="502920" y="2569464"/>
             <a:ext cx="8138160" cy="502920"/>
           </a:xfrm>
           <a:prstGeom prst="rect">
@@ -6346,7 +6368,7 @@
               </a:defRPr>
             </a:pPr>
             <a:r>
-              <a:t>• GTEx — normal tissue expression (safety window)</a:t>
+              <a:t>• ClinicalTrials.gov · ChEMBL · Open Targets · PubMed · STRING · UniProt</a:t>
             </a:r>
           </a:p>
         </p:txBody>
@@ -6359,7 +6381,7 @@
         </p:nvSpPr>
         <p:spPr>
           <a:xfrm>
-            <a:off x="502920" y="3227832"/>
+            <a:off x="502920" y="3191256"/>
             <a:ext cx="8138160" cy="502920"/>
           </a:xfrm>
           <a:prstGeom prst="rect">
@@ -6381,7 +6403,7 @@
               </a:defRPr>
             </a:pPr>
             <a:r>
-              <a:t>• DepMap — CRISPR cancer dependency screens</a:t>
+              <a:t>• Neo4j AuraDB — OncoBridge knowledge graph</a:t>
             </a:r>
           </a:p>
         </p:txBody>
@@ -6394,7 +6416,7 @@
         </p:nvSpPr>
         <p:spPr>
           <a:xfrm>
-            <a:off x="502920" y="3703320"/>
+            <a:off x="502920" y="3666744"/>
             <a:ext cx="8138160" cy="502920"/>
           </a:xfrm>
           <a:prstGeom prst="rect">
@@ -6416,42 +6438,7 @@
               </a:defRPr>
             </a:pPr>
             <a:r>
-              <a:t>• ClinicalTrials.gov · ChEMBL · Open Targets · PubMed · STRING · UniProt</a:t>
-            </a:r>
-          </a:p>
-        </p:txBody>
-      </p:sp>
-      <p:sp>
-        <p:nvSpPr>
-          <p:cNvPr id="10" name="TextBox 9"/>
-          <p:cNvSpPr txBox="1"/>
-          <p:nvPr/>
-        </p:nvSpPr>
-        <p:spPr>
-          <a:xfrm>
-            <a:off x="502920" y="4361688"/>
-            <a:ext cx="8138160" cy="502920"/>
-          </a:xfrm>
-          <a:prstGeom prst="rect">
-            <a:avLst/>
-          </a:prstGeom>
-          <a:noFill/>
-        </p:spPr>
-        <p:txBody>
-          <a:bodyPr wrap="square">
-            <a:spAutoFit/>
-          </a:bodyPr>
-          <a:lstStyle/>
-          <a:p>
-            <a:pPr algn="l">
-              <a:defRPr sz="1600" b="0">
-                <a:solidFill>
-                  <a:srgbClr val="1E293B"/>
-                </a:solidFill>
-              </a:defRPr>
-            </a:pPr>
-            <a:r>
-              <a:t>• Neo4j AuraDB — OncoBridge knowledge graph</a:t>
+              <a:t>• Same provenance layer for every target in the registry</a:t>
             </a:r>
           </a:p>
         </p:txBody>
@@ -6652,7 +6639,7 @@
               </a:defRPr>
             </a:pPr>
             <a:r>
-              <a:t>• No live link to your TCGA extracts</a:t>
+              <a:t>• No link to your TCGA extracts</a:t>
             </a:r>
           </a:p>
         </p:txBody>
@@ -6757,7 +6744,7 @@
               </a:defRPr>
             </a:pPr>
             <a:r>
-              <a:t>• Retrieves ranked TCGA expression rows</a:t>
+              <a:t>• Retrieves ranked TCGA rows per active target</a:t>
             </a:r>
           </a:p>
         </p:txBody>
@@ -6862,7 +6849,7 @@
               </a:defRPr>
             </a:pPr>
             <a:r>
-              <a:t>• Live Cypher against Neo4j graph</a:t>
+              <a:t>• Live Cypher — any of the five targets</a:t>
             </a:r>
           </a:p>
         </p:txBody>
@@ -7001,7 +6988,7 @@
               </a:defRPr>
             </a:pPr>
             <a:r>
-              <a:t>• 1. Platform Overview — scope &amp; KG scale</a:t>
+              <a:t>• 1. Platform Overview — five targets, module map, KG scale</a:t>
             </a:r>
           </a:p>
         </p:txBody>
@@ -7036,7 +7023,7 @@
               </a:defRPr>
             </a:pPr>
             <a:r>
-              <a:t>• 2. Expression Atlas (CD46) — TCGA pan-cancer chart</a:t>
+              <a:t>• 2. Compare Targets — all five genes on one chart (lead here)</a:t>
             </a:r>
           </a:p>
         </p:txBody>
@@ -7071,7 +7058,7 @@
               </a:defRPr>
             </a:pPr>
             <a:r>
-              <a:t>• 3. Compare Targets — five genes, trial funnel tab</a:t>
+              <a:t>• 3. Expression Atlas — switch target bar: FOLH1 → FAP → SSTR2</a:t>
             </a:r>
           </a:p>
         </p:txBody>
@@ -7106,7 +7093,7 @@
               </a:defRPr>
             </a:pPr>
             <a:r>
-              <a:t>• 4. KG Query Explorer — Drugs targeting CD46 (live graph)</a:t>
+              <a:t>• 4. KG Query Explorer — Drugs template per target (rotate)</a:t>
             </a:r>
           </a:p>
         </p:txBody>
@@ -7141,7 +7128,7 @@
               </a:defRPr>
             </a:pPr>
             <a:r>
-              <a:t>• 5. Research Assistant — preset survival / trial question</a:t>
+              <a:t>• 5. Research Assistant — preset for whichever target is selected</a:t>
             </a:r>
           </a:p>
         </p:txBody>
@@ -7246,7 +7233,7 @@
               </a:defRPr>
             </a:pPr>
             <a:r>
-              <a:t>Full script: reports/DEMO_RUNBOOK.md</a:t>
+              <a:t>Script: reports/DEMO_RUNBOOK.md</a:t>
             </a:r>
           </a:p>
         </p:txBody>
@@ -7307,7 +7294,7 @@
               </a:defRPr>
             </a:pPr>
             <a:r>
-              <a:t>KG Query Explorer — demo query #1</a:t>
+              <a:t>KG Query Explorer — rotate targets</a:t>
             </a:r>
           </a:p>
         </p:txBody>
@@ -7378,7 +7365,7 @@
           <a:lstStyle/>
           <a:p>
             <a:pPr algn="l">
-              <a:defRPr sz="1700" b="0">
+              <a:defRPr sz="1600" b="0">
                 <a:solidFill>
                   <a:srgbClr val="1E293B"/>
                 </a:solidFill>
@@ -7420,7 +7407,7 @@
               </a:defRPr>
             </a:pPr>
             <a:r>
-              <a:t>• Ensure CD46 selected in target bar</a:t>
+              <a:t>• Select target in the bar (e.g. FOLH1), then:</a:t>
             </a:r>
           </a:p>
         </p:txBody>
@@ -7455,7 +7442,7 @@
               </a:defRPr>
             </a:pPr>
             <a:r>
-              <a:t>• Template: 💊 Drugs: Agents targeting CD46?</a:t>
+              <a:t>• Template: 💊 Drugs: Agents targeting FOLH1?</a:t>
             </a:r>
           </a:p>
         </p:txBody>
@@ -7490,7 +7477,7 @@
               </a:defRPr>
             </a:pPr>
             <a:r>
-              <a:t>• Click Run Query → show drug name, type, max phase</a:t>
+              <a:t>• Run Query → drug name, type, max phase</a:t>
             </a:r>
           </a:p>
         </p:txBody>
@@ -7503,7 +7490,7 @@
         </p:nvSpPr>
         <p:spPr>
           <a:xfrm>
-            <a:off x="502920" y="3044952"/>
+            <a:off x="502920" y="3273552"/>
             <a:ext cx="8138160" cy="502920"/>
           </a:xfrm>
           <a:prstGeom prst="rect">
@@ -7525,7 +7512,7 @@
               </a:defRPr>
             </a:pPr>
             <a:r>
-              <a:t>• </a:t>
+              <a:t>• Repeat for FAP and SSTR2 — same templates, different symbol</a:t>
             </a:r>
           </a:p>
         </p:txBody>
@@ -7538,7 +7525,7 @@
         </p:nvSpPr>
         <p:spPr>
           <a:xfrm>
-            <a:off x="502920" y="3520440"/>
+            <a:off x="502920" y="3749039"/>
             <a:ext cx="8138160" cy="502920"/>
           </a:xfrm>
           <a:prstGeom prst="rect">
@@ -7560,7 +7547,7 @@
               </a:defRPr>
             </a:pPr>
             <a:r>
-              <a:t>• Say: “ChEMBL-linked nodes — not LLM invention.”</a:t>
+              <a:t>• Say: “One graph schema — switch the gene, rerun the query.”</a:t>
             </a:r>
           </a:p>
         </p:txBody>

</xml_diff>